<commit_message>
amended business cost table 8a
</commit_message>
<xml_diff>
--- a/images/breakeven.pptx
+++ b/images/breakeven.pptx
@@ -7,6 +7,8 @@
   <p:sldIdLst>
     <p:sldId id="256" r:id="rId2"/>
     <p:sldId id="257" r:id="rId3"/>
+    <p:sldId id="258" r:id="rId4"/>
+    <p:sldId id="259" r:id="rId5"/>
   </p:sldIdLst>
   <p:sldSz cx="12192000" cy="6858000"/>
   <p:notesSz cx="6858000" cy="9144000"/>
@@ -299,7 +301,7 @@
           <a:p>
             <a:fld id="{3B5A545A-9597-A849-ABDC-1BE79BC23987}" type="datetimeFigureOut">
               <a:rPr lang="en-US" smtClean="0"/>
-              <a:t>11/11/22</a:t>
+              <a:t>11/27/22</a:t>
             </a:fld>
             <a:endParaRPr lang="en-US"/>
           </a:p>
@@ -499,7 +501,7 @@
           <a:p>
             <a:fld id="{3B5A545A-9597-A849-ABDC-1BE79BC23987}" type="datetimeFigureOut">
               <a:rPr lang="en-US" smtClean="0"/>
-              <a:t>11/11/22</a:t>
+              <a:t>11/27/22</a:t>
             </a:fld>
             <a:endParaRPr lang="en-US"/>
           </a:p>
@@ -709,7 +711,7 @@
           <a:p>
             <a:fld id="{3B5A545A-9597-A849-ABDC-1BE79BC23987}" type="datetimeFigureOut">
               <a:rPr lang="en-US" smtClean="0"/>
-              <a:t>11/11/22</a:t>
+              <a:t>11/27/22</a:t>
             </a:fld>
             <a:endParaRPr lang="en-US"/>
           </a:p>
@@ -909,7 +911,7 @@
           <a:p>
             <a:fld id="{3B5A545A-9597-A849-ABDC-1BE79BC23987}" type="datetimeFigureOut">
               <a:rPr lang="en-US" smtClean="0"/>
-              <a:t>11/11/22</a:t>
+              <a:t>11/27/22</a:t>
             </a:fld>
             <a:endParaRPr lang="en-US"/>
           </a:p>
@@ -1185,7 +1187,7 @@
           <a:p>
             <a:fld id="{3B5A545A-9597-A849-ABDC-1BE79BC23987}" type="datetimeFigureOut">
               <a:rPr lang="en-US" smtClean="0"/>
-              <a:t>11/11/22</a:t>
+              <a:t>11/27/22</a:t>
             </a:fld>
             <a:endParaRPr lang="en-US"/>
           </a:p>
@@ -1453,7 +1455,7 @@
           <a:p>
             <a:fld id="{3B5A545A-9597-A849-ABDC-1BE79BC23987}" type="datetimeFigureOut">
               <a:rPr lang="en-US" smtClean="0"/>
-              <a:t>11/11/22</a:t>
+              <a:t>11/27/22</a:t>
             </a:fld>
             <a:endParaRPr lang="en-US"/>
           </a:p>
@@ -1868,7 +1870,7 @@
           <a:p>
             <a:fld id="{3B5A545A-9597-A849-ABDC-1BE79BC23987}" type="datetimeFigureOut">
               <a:rPr lang="en-US" smtClean="0"/>
-              <a:t>11/11/22</a:t>
+              <a:t>11/27/22</a:t>
             </a:fld>
             <a:endParaRPr lang="en-US"/>
           </a:p>
@@ -2010,7 +2012,7 @@
           <a:p>
             <a:fld id="{3B5A545A-9597-A849-ABDC-1BE79BC23987}" type="datetimeFigureOut">
               <a:rPr lang="en-US" smtClean="0"/>
-              <a:t>11/11/22</a:t>
+              <a:t>11/27/22</a:t>
             </a:fld>
             <a:endParaRPr lang="en-US"/>
           </a:p>
@@ -2123,7 +2125,7 @@
           <a:p>
             <a:fld id="{3B5A545A-9597-A849-ABDC-1BE79BC23987}" type="datetimeFigureOut">
               <a:rPr lang="en-US" smtClean="0"/>
-              <a:t>11/11/22</a:t>
+              <a:t>11/27/22</a:t>
             </a:fld>
             <a:endParaRPr lang="en-US"/>
           </a:p>
@@ -2436,7 +2438,7 @@
           <a:p>
             <a:fld id="{3B5A545A-9597-A849-ABDC-1BE79BC23987}" type="datetimeFigureOut">
               <a:rPr lang="en-US" smtClean="0"/>
-              <a:t>11/11/22</a:t>
+              <a:t>11/27/22</a:t>
             </a:fld>
             <a:endParaRPr lang="en-US"/>
           </a:p>
@@ -2725,7 +2727,7 @@
           <a:p>
             <a:fld id="{3B5A545A-9597-A849-ABDC-1BE79BC23987}" type="datetimeFigureOut">
               <a:rPr lang="en-US" smtClean="0"/>
-              <a:t>11/11/22</a:t>
+              <a:t>11/27/22</a:t>
             </a:fld>
             <a:endParaRPr lang="en-US"/>
           </a:p>
@@ -2968,7 +2970,7 @@
           <a:p>
             <a:fld id="{3B5A545A-9597-A849-ABDC-1BE79BC23987}" type="datetimeFigureOut">
               <a:rPr lang="en-US" smtClean="0"/>
-              <a:t>11/11/22</a:t>
+              <a:t>11/27/22</a:t>
             </a:fld>
             <a:endParaRPr lang="en-US"/>
           </a:p>
@@ -3992,6 +3994,360 @@
 </p:sld>
 </file>
 
+<file path=ppt/slides/slide3.xml><?xml version="1.0" encoding="utf-8"?>
+<p:sld xmlns:a="http://schemas.openxmlformats.org/drawingml/2006/main" xmlns:r="http://schemas.openxmlformats.org/officeDocument/2006/relationships" xmlns:p="http://schemas.openxmlformats.org/presentationml/2006/main">
+  <p:cSld>
+    <p:spTree>
+      <p:nvGrpSpPr>
+        <p:cNvPr id="1" name=""/>
+        <p:cNvGrpSpPr/>
+        <p:nvPr/>
+      </p:nvGrpSpPr>
+      <p:grpSpPr>
+        <a:xfrm>
+          <a:off x="0" y="0"/>
+          <a:ext cx="0" cy="0"/>
+          <a:chOff x="0" y="0"/>
+          <a:chExt cx="0" cy="0"/>
+        </a:xfrm>
+      </p:grpSpPr>
+      <p:pic>
+        <p:nvPicPr>
+          <p:cNvPr id="2" name="Picture 1">
+            <a:extLst>
+              <a:ext uri="{FF2B5EF4-FFF2-40B4-BE49-F238E27FC236}">
+                <a16:creationId xmlns:a16="http://schemas.microsoft.com/office/drawing/2014/main" id="{9BF3F161-1AB3-A6D7-BFB1-AF91814C476F}"/>
+              </a:ext>
+            </a:extLst>
+          </p:cNvPr>
+          <p:cNvPicPr>
+            <a:picLocks noChangeAspect="1"/>
+          </p:cNvPicPr>
+          <p:nvPr/>
+        </p:nvPicPr>
+        <p:blipFill>
+          <a:blip r:embed="rId2"/>
+          <a:stretch>
+            <a:fillRect/>
+          </a:stretch>
+        </p:blipFill>
+        <p:spPr>
+          <a:xfrm>
+            <a:off x="3181350" y="2095500"/>
+            <a:ext cx="5829300" cy="2667000"/>
+          </a:xfrm>
+          <a:prstGeom prst="rect">
+            <a:avLst/>
+          </a:prstGeom>
+        </p:spPr>
+      </p:pic>
+    </p:spTree>
+    <p:extLst>
+      <p:ext uri="{BB962C8B-B14F-4D97-AF65-F5344CB8AC3E}">
+        <p14:creationId xmlns:p14="http://schemas.microsoft.com/office/powerpoint/2010/main" val="275286662"/>
+      </p:ext>
+    </p:extLst>
+  </p:cSld>
+  <p:clrMapOvr>
+    <a:masterClrMapping/>
+  </p:clrMapOvr>
+</p:sld>
+</file>
+
+<file path=ppt/slides/slide4.xml><?xml version="1.0" encoding="utf-8"?>
+<p:sld xmlns:a="http://schemas.openxmlformats.org/drawingml/2006/main" xmlns:r="http://schemas.openxmlformats.org/officeDocument/2006/relationships" xmlns:p="http://schemas.openxmlformats.org/presentationml/2006/main">
+  <p:cSld>
+    <p:spTree>
+      <p:nvGrpSpPr>
+        <p:cNvPr id="1" name=""/>
+        <p:cNvGrpSpPr/>
+        <p:nvPr/>
+      </p:nvGrpSpPr>
+      <p:grpSpPr>
+        <a:xfrm>
+          <a:off x="0" y="0"/>
+          <a:ext cx="0" cy="0"/>
+          <a:chOff x="0" y="0"/>
+          <a:chExt cx="0" cy="0"/>
+        </a:xfrm>
+      </p:grpSpPr>
+      <p:sp>
+        <p:nvSpPr>
+          <p:cNvPr id="3" name="TextBox 2">
+            <a:extLst>
+              <a:ext uri="{FF2B5EF4-FFF2-40B4-BE49-F238E27FC236}">
+                <a16:creationId xmlns:a16="http://schemas.microsoft.com/office/drawing/2014/main" id="{A1DBB9AF-BD05-3076-28D3-E10090CB1E9E}"/>
+              </a:ext>
+            </a:extLst>
+          </p:cNvPr>
+          <p:cNvSpPr txBox="1"/>
+          <p:nvPr/>
+        </p:nvSpPr>
+        <p:spPr>
+          <a:xfrm>
+            <a:off x="3050381" y="335846"/>
+            <a:ext cx="6100762" cy="6186309"/>
+          </a:xfrm>
+          <a:prstGeom prst="rect">
+            <a:avLst/>
+          </a:prstGeom>
+          <a:noFill/>
+        </p:spPr>
+        <p:txBody>
+          <a:bodyPr wrap="square">
+            <a:spAutoFit/>
+          </a:bodyPr>
+          <a:lstStyle/>
+          <a:p>
+            <a:r>
+              <a:rPr lang="en-GB" dirty="0"/>
+              <a:t>&lt;!--#\</a:t>
+            </a:r>
+            <a:r>
+              <a:rPr lang="en-GB" dirty="0" err="1"/>
+              <a:t>captionof</a:t>
+            </a:r>
+            <a:r>
+              <a:rPr lang="en-GB" dirty="0"/>
+              <a:t>{table}{}  --&gt;</a:t>
+            </a:r>
+          </a:p>
+          <a:p>
+            <a:endParaRPr lang="en-GB" dirty="0"/>
+          </a:p>
+          <a:p>
+            <a:r>
+              <a:rPr lang="en-GB" dirty="0"/>
+              <a:t>```{r balance, message=FALSE, warning=FALSE, echo=FALSE, include=FALSE}</a:t>
+            </a:r>
+          </a:p>
+          <a:p>
+            <a:r>
+              <a:rPr lang="en-GB" dirty="0"/>
+              <a:t>rm(list=ls())</a:t>
+            </a:r>
+          </a:p>
+          <a:p>
+            <a:r>
+              <a:rPr lang="en-GB" dirty="0"/>
+              <a:t>library(</a:t>
+            </a:r>
+            <a:r>
+              <a:rPr lang="en-GB" dirty="0" err="1"/>
+              <a:t>readxl</a:t>
+            </a:r>
+            <a:r>
+              <a:rPr lang="en-GB" dirty="0"/>
+              <a:t>)</a:t>
+            </a:r>
+          </a:p>
+          <a:p>
+            <a:r>
+              <a:rPr lang="en-GB" dirty="0"/>
+              <a:t>library(</a:t>
+            </a:r>
+            <a:r>
+              <a:rPr lang="en-GB" dirty="0" err="1"/>
+              <a:t>knitr</a:t>
+            </a:r>
+            <a:r>
+              <a:rPr lang="en-GB" dirty="0"/>
+              <a:t>)</a:t>
+            </a:r>
+          </a:p>
+          <a:p>
+            <a:r>
+              <a:rPr lang="en-GB" dirty="0"/>
+              <a:t>library(</a:t>
+            </a:r>
+            <a:r>
+              <a:rPr lang="en-GB" dirty="0" err="1"/>
+              <a:t>kableExtra</a:t>
+            </a:r>
+            <a:r>
+              <a:rPr lang="en-GB" dirty="0"/>
+              <a:t>)</a:t>
+            </a:r>
+          </a:p>
+          <a:p>
+            <a:r>
+              <a:rPr lang="en-GB" dirty="0"/>
+              <a:t>library(</a:t>
+            </a:r>
+            <a:r>
+              <a:rPr lang="en-GB" dirty="0" err="1"/>
+              <a:t>knitr</a:t>
+            </a:r>
+            <a:r>
+              <a:rPr lang="en-GB" dirty="0"/>
+              <a:t>)</a:t>
+            </a:r>
+          </a:p>
+          <a:p>
+            <a:endParaRPr lang="en-GB" dirty="0"/>
+          </a:p>
+          <a:p>
+            <a:endParaRPr lang="en-GB" dirty="0"/>
+          </a:p>
+          <a:p>
+            <a:r>
+              <a:rPr lang="en-GB" dirty="0" err="1"/>
+              <a:t>dat</a:t>
+            </a:r>
+            <a:r>
+              <a:rPr lang="en-GB" dirty="0"/>
+              <a:t> &lt;-</a:t>
+            </a:r>
+            <a:r>
+              <a:rPr lang="en-GB" dirty="0" err="1"/>
+              <a:t>read_excel</a:t>
+            </a:r>
+            <a:r>
+              <a:rPr lang="en-GB" dirty="0"/>
+              <a:t>("/Users/</a:t>
+            </a:r>
+            <a:r>
+              <a:rPr lang="en-GB" dirty="0" err="1"/>
+              <a:t>ahmaddaryanto</a:t>
+            </a:r>
+            <a:r>
+              <a:rPr lang="en-GB" dirty="0"/>
+              <a:t>/OneDrive - Lancaster University/</a:t>
+            </a:r>
+            <a:r>
+              <a:rPr lang="en-GB" dirty="0" err="1"/>
+              <a:t>numbook</a:t>
+            </a:r>
+            <a:r>
+              <a:rPr lang="en-GB" dirty="0"/>
+              <a:t>/data/</a:t>
+            </a:r>
+            <a:r>
+              <a:rPr lang="en-GB" dirty="0" err="1"/>
+              <a:t>balance.xlsx</a:t>
+            </a:r>
+            <a:r>
+              <a:rPr lang="en-GB" dirty="0"/>
+              <a:t>")</a:t>
+            </a:r>
+          </a:p>
+          <a:p>
+            <a:endParaRPr lang="en-GB" dirty="0"/>
+          </a:p>
+          <a:p>
+            <a:r>
+              <a:rPr lang="en-GB" dirty="0" err="1"/>
+              <a:t>dat</a:t>
+            </a:r>
+            <a:r>
+              <a:rPr lang="en-GB" dirty="0"/>
+              <a:t> %&gt;%</a:t>
+            </a:r>
+          </a:p>
+          <a:p>
+            <a:r>
+              <a:rPr lang="en-GB" dirty="0"/>
+              <a:t>  </a:t>
+            </a:r>
+            <a:r>
+              <a:rPr lang="en-GB" dirty="0" err="1"/>
+              <a:t>kbl</a:t>
+            </a:r>
+            <a:r>
+              <a:rPr lang="en-GB" dirty="0"/>
+              <a:t>(caption = "Your Business (December)") %&gt;%</a:t>
+            </a:r>
+          </a:p>
+          <a:p>
+            <a:r>
+              <a:rPr lang="en-GB" dirty="0"/>
+              <a:t>  </a:t>
+            </a:r>
+            <a:r>
+              <a:rPr lang="en-GB" dirty="0" err="1"/>
+              <a:t>kable_classic</a:t>
+            </a:r>
+            <a:r>
+              <a:rPr lang="en-GB" dirty="0"/>
+              <a:t>(</a:t>
+            </a:r>
+            <a:r>
+              <a:rPr lang="en-GB" dirty="0" err="1"/>
+              <a:t>full_width</a:t>
+            </a:r>
+            <a:r>
+              <a:rPr lang="en-GB" dirty="0"/>
+              <a:t> = F, </a:t>
+            </a:r>
+            <a:r>
+              <a:rPr lang="en-GB" dirty="0" err="1"/>
+              <a:t>html_font</a:t>
+            </a:r>
+            <a:r>
+              <a:rPr lang="en-GB" dirty="0"/>
+              <a:t> = "Cambria") %&gt;%</a:t>
+            </a:r>
+          </a:p>
+          <a:p>
+            <a:r>
+              <a:rPr lang="en-GB" dirty="0"/>
+              <a:t>  </a:t>
+            </a:r>
+            <a:r>
+              <a:rPr lang="en-GB" dirty="0" err="1"/>
+              <a:t>row_spec</a:t>
+            </a:r>
+            <a:r>
+              <a:rPr lang="en-GB" dirty="0"/>
+              <a:t>(6, </a:t>
+            </a:r>
+            <a:r>
+              <a:rPr lang="en-GB" dirty="0" err="1"/>
+              <a:t>color</a:t>
+            </a:r>
+            <a:r>
+              <a:rPr lang="en-GB" dirty="0"/>
+              <a:t> = 'white', background = 'black') %&gt;%</a:t>
+            </a:r>
+          </a:p>
+          <a:p>
+            <a:r>
+              <a:rPr lang="en-GB" dirty="0"/>
+              <a:t> </a:t>
+            </a:r>
+            <a:r>
+              <a:rPr lang="en-GB" dirty="0" err="1"/>
+              <a:t>add_footnote</a:t>
+            </a:r>
+            <a:r>
+              <a:rPr lang="en-GB" dirty="0"/>
+              <a:t>(c("Note: Number in the last row is a count"), notation = "symbol")</a:t>
+            </a:r>
+          </a:p>
+          <a:p>
+            <a:endParaRPr lang="en-GB" dirty="0"/>
+          </a:p>
+          <a:p>
+            <a:r>
+              <a:rPr lang="en-GB" dirty="0"/>
+              <a:t>```</a:t>
+            </a:r>
+          </a:p>
+        </p:txBody>
+      </p:sp>
+    </p:spTree>
+    <p:extLst>
+      <p:ext uri="{BB962C8B-B14F-4D97-AF65-F5344CB8AC3E}">
+        <p14:creationId xmlns:p14="http://schemas.microsoft.com/office/powerpoint/2010/main" val="2291475710"/>
+      </p:ext>
+    </p:extLst>
+  </p:cSld>
+  <p:clrMapOvr>
+    <a:masterClrMapping/>
+  </p:clrMapOvr>
+</p:sld>
+</file>
+
 <file path=ppt/theme/theme1.xml><?xml version="1.0" encoding="utf-8"?>
 <a:theme xmlns:a="http://schemas.openxmlformats.org/drawingml/2006/main" name="Office Theme">
   <a:themeElements>

</xml_diff>